<commit_message>
deck(scale rung): the llvm-project kicker reads larger, with 182,555 in bold
Slide 10 only. The kicker is 18 pt across the full content width instead of kicker() at 13 pt, and the file
count is the bold run: it is the slide's claim. The other kickers are unchanged.

deckcheck, deckclaimcheck (179 long flags, 34 slides) and readmedriftcheck pass; pptx and PDF regenerated
(pptxgenjs 4.0.1, LibreOffice impress_pdf_Export, 34 pages).

Co-Authored-By: Claude Opus 5 <noreply@anthropic.com>
</commit_message>
<xml_diff>
--- a/present/ripwire-showcase.pptx
+++ b/present/ripwire-showcase.pptx
@@ -5167,24 +5167,24 @@
         </p:nvSpPr>
         <p:spPr>
           <a:xfrm>
-            <a:off x="566928" y="384048"/>
-            <a:ext cx="8229600" cy="292608"/>
-          </a:xfrm>
-          <a:prstGeom prst="rect">
-            <a:avLst/>
-          </a:prstGeom>
-          <a:noFill/>
-          <a:ln/>
-        </p:spPr>
-        <p:txBody>
-          <a:bodyPr wrap="square" lIns="0" tIns="0" rIns="0" bIns="0" rtlCol="0" anchor="ctr"/>
-          <a:lstStyle/>
-          <a:p>
-            <a:pPr indent="0" marL="0">
-              <a:buNone/>
-            </a:pPr>
-            <a:r>
-              <a:rPr lang="en-US" sz="1300" dirty="0">
+            <a:off x="566928" y="310896"/>
+            <a:ext cx="11055096" cy="384048"/>
+          </a:xfrm>
+          <a:prstGeom prst="rect">
+            <a:avLst/>
+          </a:prstGeom>
+          <a:noFill/>
+          <a:ln/>
+        </p:spPr>
+        <p:txBody>
+          <a:bodyPr wrap="square" lIns="0" tIns="0" rIns="0" bIns="0" rtlCol="0" anchor="ctr"/>
+          <a:lstStyle/>
+          <a:p>
+            <a:pPr indent="0" marL="0">
+              <a:buNone/>
+            </a:pPr>
+            <a:r>
+              <a:rPr lang="en-US" sz="1800" dirty="0">
                 <a:solidFill>
                   <a:srgbClr val="56D6E8"/>
                 </a:solidFill>
@@ -5192,9 +5192,37 @@
                 <a:ea typeface="Courier New" pitchFamily="34" charset="-122"/>
                 <a:cs typeface="Courier New" pitchFamily="34" charset="-120"/>
               </a:rPr>
-              <a:t>// Rip'n Fast, at scale — llvm-project, 182,555 files, as the instrument</a:t>
-            </a:r>
-            <a:endParaRPr lang="en-US" sz="1300" dirty="0"/>
+              <a:t>// Rip'n Fast, at scale — llvm-project, </a:t>
+            </a:r>
+            <a:pPr indent="0" marL="0">
+              <a:buNone/>
+            </a:pPr>
+            <a:r>
+              <a:rPr lang="en-US" sz="1800" b="1" dirty="0">
+                <a:solidFill>
+                  <a:srgbClr val="56D6E8"/>
+                </a:solidFill>
+                <a:latin typeface="Courier New" pitchFamily="34" charset="0"/>
+                <a:ea typeface="Courier New" pitchFamily="34" charset="-122"/>
+                <a:cs typeface="Courier New" pitchFamily="34" charset="-120"/>
+              </a:rPr>
+              <a:t>182,555</a:t>
+            </a:r>
+            <a:pPr indent="0" marL="0">
+              <a:buNone/>
+            </a:pPr>
+            <a:r>
+              <a:rPr lang="en-US" sz="1800" dirty="0">
+                <a:solidFill>
+                  <a:srgbClr val="56D6E8"/>
+                </a:solidFill>
+                <a:latin typeface="Courier New" pitchFamily="34" charset="0"/>
+                <a:ea typeface="Courier New" pitchFamily="34" charset="-122"/>
+                <a:cs typeface="Courier New" pitchFamily="34" charset="-120"/>
+              </a:rPr>
+              <a:t> files, as the instrument</a:t>
+            </a:r>
+            <a:endParaRPr lang="en-US" sz="1800" dirty="0"/>
           </a:p>
         </p:txBody>
       </p:sp>

</xml_diff>